<commit_message>
Label unopened sources as confirm and keep the phone tour off the headline.
Rooms, chapters, and downloads keep a Sources and go deeper block with last checked 2026-10. Pages that did not open are confirm text with no URL. The first tour card sits below the title, and footer chrome stays on the website, GitHub organization, and Linktree.

Co-authored-by: CYPHER0X9 <cipher0x9@users.noreply.github.com>
</commit_message>
<xml_diff>
--- a/downloads/teams-phone-deck.pptx
+++ b/downloads/teams-phone-deck.pptx
@@ -1049,7 +1049,7 @@
           <a:p>
             <a:r>
               <a:rPr lang="en-US" sz="1400"/>
-              <a:t>Cloud Voicemail — confirm — https://learn.microsoft.com/en-us/microsoftteams/cloud-voicemail — last checked 2026-10. Did not open when checked.</a:t>
+              <a:t>Cloud Voicemail — confirm — last checked 2026-10. Did not open when checked.</a:t>
             </a:r>
           </a:p>
           <a:p>
@@ -1500,7 +1500,7 @@
           <a:p>
             <a:r>
               <a:rPr lang="en-US" sz="1400"/>
-              <a:t>Plan Teams Phone Mobile — confirm — https://learn.microsoft.com/en-us/microsoftteams/teams-phone-mobile-plan — last checked 2026-10. Did not open when checked.</a:t>
+              <a:t>Plan Teams Phone Mobile — confirm — last checked 2026-10. Did not open when checked.</a:t>
             </a:r>
           </a:p>
           <a:p>
@@ -1779,7 +1779,7 @@
           <a:p>
             <a:r>
               <a:rPr lang="en-US" sz="1400"/>
-              <a:t>AudioCodes session border controllers — confirm — https://www.audiocodes.com/solutions-products/products/session-border-controllers — last checked 2026-10. Did not open when checked.</a:t>
+              <a:t>AudioCodes session border controllers — confirm — last checked 2026-10. Did not open when checked.</a:t>
             </a:r>
           </a:p>
         </p:txBody>
@@ -1862,13 +1862,13 @@
           <a:p>
             <a:r>
               <a:rPr lang="en-US" sz="1400"/>
-              <a:t>Cisco Unified Border Element — vendor — https://www.cisco.com/c/en/us/products/unified-communications/unified-border-element/index.html — last checked 2026-10</a:t>
-            </a:r>
-          </a:p>
-          <a:p>
-            <a:r>
-              <a:rPr lang="en-US" sz="1400"/>
-              <a:t>Oracle Session Border Controller — confirm — https://www.oracle.com/communications/session-border-controller/ — last checked 2026-10. Did not open when checked.</a:t>
+              <a:t>Cisco Unified Border Element — confirm — last checked 2026-10. Did not open when checked.</a:t>
+            </a:r>
+          </a:p>
+          <a:p>
+            <a:r>
+              <a:rPr lang="en-US" sz="1400"/>
+              <a:t>Oracle Session Border Controller — confirm — last checked 2026-10. Did not open when checked.</a:t>
             </a:r>
           </a:p>
         </p:txBody>

</xml_diff>

<commit_message>
Label unopened sources as confirm and keep the phone tour off the headline. (#8)
Rooms, chapters, and downloads keep a Sources and go deeper block with last checked 2026-10. Pages that did not open are confirm text with no URL. The first tour card sits below the title, and footer chrome stays on the website, GitHub organization, and Linktree.

Co-authored-by: Cursor Agent <cursoragent@cursor.com>
Co-authored-by: CYPHER0X9 <cipher0x9@users.noreply.github.com>
</commit_message>
<xml_diff>
--- a/downloads/teams-phone-deck.pptx
+++ b/downloads/teams-phone-deck.pptx
@@ -1049,7 +1049,7 @@
           <a:p>
             <a:r>
               <a:rPr lang="en-US" sz="1400"/>
-              <a:t>Cloud Voicemail — confirm — https://learn.microsoft.com/en-us/microsoftteams/cloud-voicemail — last checked 2026-10. Did not open when checked.</a:t>
+              <a:t>Cloud Voicemail — confirm — last checked 2026-10. Did not open when checked.</a:t>
             </a:r>
           </a:p>
           <a:p>
@@ -1500,7 +1500,7 @@
           <a:p>
             <a:r>
               <a:rPr lang="en-US" sz="1400"/>
-              <a:t>Plan Teams Phone Mobile — confirm — https://learn.microsoft.com/en-us/microsoftteams/teams-phone-mobile-plan — last checked 2026-10. Did not open when checked.</a:t>
+              <a:t>Plan Teams Phone Mobile — confirm — last checked 2026-10. Did not open when checked.</a:t>
             </a:r>
           </a:p>
           <a:p>
@@ -1779,7 +1779,7 @@
           <a:p>
             <a:r>
               <a:rPr lang="en-US" sz="1400"/>
-              <a:t>AudioCodes session border controllers — confirm — https://www.audiocodes.com/solutions-products/products/session-border-controllers — last checked 2026-10. Did not open when checked.</a:t>
+              <a:t>AudioCodes session border controllers — confirm — last checked 2026-10. Did not open when checked.</a:t>
             </a:r>
           </a:p>
         </p:txBody>
@@ -1862,13 +1862,13 @@
           <a:p>
             <a:r>
               <a:rPr lang="en-US" sz="1400"/>
-              <a:t>Cisco Unified Border Element — vendor — https://www.cisco.com/c/en/us/products/unified-communications/unified-border-element/index.html — last checked 2026-10</a:t>
-            </a:r>
-          </a:p>
-          <a:p>
-            <a:r>
-              <a:rPr lang="en-US" sz="1400"/>
-              <a:t>Oracle Session Border Controller — confirm — https://www.oracle.com/communications/session-border-controller/ — last checked 2026-10. Did not open when checked.</a:t>
+              <a:t>Cisco Unified Border Element — confirm — last checked 2026-10. Did not open when checked.</a:t>
+            </a:r>
+          </a:p>
+          <a:p>
+            <a:r>
+              <a:rPr lang="en-US" sz="1400"/>
+              <a:t>Oracle Session Border Controller — confirm — last checked 2026-10. Did not open when checked.</a:t>
             </a:r>
           </a:p>
         </p:txBody>

</xml_diff>